<commit_message>
Remove speaker notes from Grade 1 and Grade 7 Past Perfect decks.
</commit_message>
<xml_diff>
--- a/Grade1_Little_Rabbit_Reading_30min.pptx
+++ b/Grade1_Little_Rabbit_Reading_30min.pptx
@@ -528,66 +528,7 @@
         <p:txBody>
           <a:bodyPr/>
           <a:lstStyle/>
-          <a:p>
-            <a:r>
-              <a:t>WHAT TO SAY:</a:t>
-            </a:r>
-          </a:p>
-          <a:p>
-            <a:r>
-              <a:t>Hi Reading Star! We play, read, and meet Ben the rabbit!</a:t>
-            </a:r>
-          </a:p>
           <a:p/>
-          <a:p>
-            <a:r>
-              <a:t>QUESTION TO ASK:</a:t>
-            </a:r>
-          </a:p>
-          <a:p>
-            <a:r>
-              <a:t>What's your name?</a:t>
-            </a:r>
-          </a:p>
-          <a:p/>
-          <a:p>
-            <a:r>
-              <a:t>EXPECTED ANSWER:</a:t>
-            </a:r>
-          </a:p>
-          <a:p>
-            <a:r>
-              <a:t>Child says name.</a:t>
-            </a:r>
-          </a:p>
-          <a:p/>
-          <a:p>
-            <a:r>
-              <a:t>IF CHILD STRUGGLES:</a:t>
-            </a:r>
-          </a:p>
-          <a:p>
-            <a:r>
-              <a:t>Model your name.</a:t>
-            </a:r>
-          </a:p>
-          <a:p/>
-          <a:p>
-            <a:r>
-              <a:t>ENCOURAGING PHRASES:</a:t>
-            </a:r>
-          </a:p>
-          <a:p>
-            <a:r>
-              <a:t>Excellent!</a:t>
-            </a:r>
-          </a:p>
-          <a:p/>
-          <a:p>
-            <a:r>
-              <a:t>TIMING: 0–2 min</a:t>
-            </a:r>
-          </a:p>
         </p:txBody>
       </p:sp>
       <p:sp>
@@ -653,88 +594,7 @@
         <p:txBody>
           <a:bodyPr/>
           <a:lstStyle/>
-          <a:p>
-            <a:r>
-              <a:t>WHAT TO SAY:</a:t>
-            </a:r>
-          </a:p>
-          <a:p>
-            <a:r>
-              <a:t>Pick the story word!</a:t>
-            </a:r>
-          </a:p>
           <a:p/>
-          <a:p>
-            <a:r>
-              <a:t>QUESTION TO ASK:</a:t>
-            </a:r>
-          </a:p>
-          <a:p>
-            <a:r>
-              <a:t>Which one?</a:t>
-            </a:r>
-          </a:p>
-          <a:p/>
-          <a:p>
-            <a:r>
-              <a:t>EXPECTED ANSWER:</a:t>
-            </a:r>
-          </a:p>
-          <a:p>
-            <a:r>
-              <a:t>BALL</a:t>
-            </a:r>
-          </a:p>
-          <a:p/>
-          <a:p>
-            <a:r>
-              <a:t>IF CHILD STRUGGLES:</a:t>
-            </a:r>
-          </a:p>
-          <a:p>
-            <a:r>
-              <a:t>Say each aloud.</a:t>
-            </a:r>
-          </a:p>
-          <a:p/>
-          <a:p>
-            <a:r>
-              <a:t>ENCOURAGING PHRASES:</a:t>
-            </a:r>
-          </a:p>
-          <a:p>
-            <a:r>
-              <a:t>Yum!</a:t>
-            </a:r>
-          </a:p>
-          <a:p/>
-          <a:p>
-            <a:r>
-              <a:t>EASIER OPTION:</a:t>
-            </a:r>
-          </a:p>
-          <a:p>
-            <a:r>
-              <a:t>Two choices.</a:t>
-            </a:r>
-          </a:p>
-          <a:p/>
-          <a:p>
-            <a:r>
-              <a:t>HARDER OPTION:</a:t>
-            </a:r>
-          </a:p>
-          <a:p>
-            <a:r>
-              <a:t>Why pick it?</a:t>
-            </a:r>
-          </a:p>
-          <a:p/>
-          <a:p>
-            <a:r>
-              <a:t>TIMING: 9–10 min</a:t>
-            </a:r>
-          </a:p>
         </p:txBody>
       </p:sp>
       <p:sp>
@@ -800,88 +660,7 @@
         <p:txBody>
           <a:bodyPr/>
           <a:lstStyle/>
-          <a:p>
-            <a:r>
-              <a:t>WHAT TO SAY:</a:t>
-            </a:r>
-          </a:p>
-          <a:p>
-            <a:r>
-              <a:t>Draw a line with your finger!</a:t>
-            </a:r>
-          </a:p>
           <a:p/>
-          <a:p>
-            <a:r>
-              <a:t>QUESTION TO ASK:</a:t>
-            </a:r>
-          </a:p>
-          <a:p>
-            <a:r>
-              <a:t>Which word goes with rabbit?</a:t>
-            </a:r>
-          </a:p>
-          <a:p/>
-          <a:p>
-            <a:r>
-              <a:t>EXPECTED ANSWER:</a:t>
-            </a:r>
-          </a:p>
-          <a:p>
-            <a:r>
-              <a:t>rabbit-tree-ball-sun</a:t>
-            </a:r>
-          </a:p>
-          <a:p/>
-          <a:p>
-            <a:r>
-              <a:t>IF CHILD STRUGGLES:</a:t>
-            </a:r>
-          </a:p>
-          <a:p>
-            <a:r>
-              <a:t>Say both together.</a:t>
-            </a:r>
-          </a:p>
-          <a:p/>
-          <a:p>
-            <a:r>
-              <a:t>ENCOURAGING PHRASES:</a:t>
-            </a:r>
-          </a:p>
-          <a:p>
-            <a:r>
-              <a:t>Perfect match!</a:t>
-            </a:r>
-          </a:p>
-          <a:p/>
-          <a:p>
-            <a:r>
-              <a:t>EASIER OPTION:</a:t>
-            </a:r>
-          </a:p>
-          <a:p>
-            <a:r>
-              <a:t>One pair at a time.</a:t>
-            </a:r>
-          </a:p>
-          <a:p/>
-          <a:p>
-            <a:r>
-              <a:t>HARDER OPTION:</a:t>
-            </a:r>
-          </a:p>
-          <a:p>
-            <a:r>
-              <a:t>Make a sentence.</a:t>
-            </a:r>
-          </a:p>
-          <a:p/>
-          <a:p>
-            <a:r>
-              <a:t>TIMING: 10–11 min</a:t>
-            </a:r>
-          </a:p>
         </p:txBody>
       </p:sp>
       <p:sp>
@@ -947,88 +726,7 @@
         <p:txBody>
           <a:bodyPr/>
           <a:lstStyle/>
-          <a:p>
-            <a:r>
-              <a:t>WHAT TO SAY:</a:t>
-            </a:r>
-          </a:p>
-          <a:p>
-            <a:r>
-              <a:t>One sentence at a time. Big praise!</a:t>
-            </a:r>
-          </a:p>
           <a:p/>
-          <a:p>
-            <a:r>
-              <a:t>QUESTION TO ASK:</a:t>
-            </a:r>
-          </a:p>
-          <a:p>
-            <a:r>
-              <a:t>Read one line.</a:t>
-            </a:r>
-          </a:p>
-          <a:p/>
-          <a:p>
-            <a:r>
-              <a:t>EXPECTED ANSWER:</a:t>
-            </a:r>
-          </a:p>
-          <a:p>
-            <a:r>
-              <a:t>Child reads with finger tracking.</a:t>
-            </a:r>
-          </a:p>
-          <a:p/>
-          <a:p>
-            <a:r>
-              <a:t>IF CHILD STRUGGLES:</a:t>
-            </a:r>
-          </a:p>
-          <a:p>
-            <a:r>
-              <a:t>Echo read together.</a:t>
-            </a:r>
-          </a:p>
-          <a:p/>
-          <a:p>
-            <a:r>
-              <a:t>ENCOURAGING PHRASES:</a:t>
-            </a:r>
-          </a:p>
-          <a:p>
-            <a:r>
-              <a:t>Excellent! / You read that!</a:t>
-            </a:r>
-          </a:p>
-          <a:p/>
-          <a:p>
-            <a:r>
-              <a:t>EASIER OPTION:</a:t>
-            </a:r>
-          </a:p>
-          <a:p>
-            <a:r>
-              <a:t>Repeat after me.</a:t>
-            </a:r>
-          </a:p>
-          <a:p/>
-          <a:p>
-            <a:r>
-              <a:t>HARDER OPTION:</a:t>
-            </a:r>
-          </a:p>
-          <a:p>
-            <a:r>
-              <a:t>Child reads alone.</a:t>
-            </a:r>
-          </a:p>
-          <a:p/>
-          <a:p>
-            <a:r>
-              <a:t>TIMING: 11–12 min</a:t>
-            </a:r>
-          </a:p>
         </p:txBody>
       </p:sp>
       <p:sp>
@@ -1094,88 +792,7 @@
         <p:txBody>
           <a:bodyPr/>
           <a:lstStyle/>
-          <a:p>
-            <a:r>
-              <a:t>WHAT TO SAY:</a:t>
-            </a:r>
-          </a:p>
-          <a:p>
-            <a:r>
-              <a:t>One sentence at a time. Big praise!</a:t>
-            </a:r>
-          </a:p>
           <a:p/>
-          <a:p>
-            <a:r>
-              <a:t>QUESTION TO ASK:</a:t>
-            </a:r>
-          </a:p>
-          <a:p>
-            <a:r>
-              <a:t>Read one line.</a:t>
-            </a:r>
-          </a:p>
-          <a:p/>
-          <a:p>
-            <a:r>
-              <a:t>EXPECTED ANSWER:</a:t>
-            </a:r>
-          </a:p>
-          <a:p>
-            <a:r>
-              <a:t>Child reads with finger tracking.</a:t>
-            </a:r>
-          </a:p>
-          <a:p/>
-          <a:p>
-            <a:r>
-              <a:t>IF CHILD STRUGGLES:</a:t>
-            </a:r>
-          </a:p>
-          <a:p>
-            <a:r>
-              <a:t>Echo read together.</a:t>
-            </a:r>
-          </a:p>
-          <a:p/>
-          <a:p>
-            <a:r>
-              <a:t>ENCOURAGING PHRASES:</a:t>
-            </a:r>
-          </a:p>
-          <a:p>
-            <a:r>
-              <a:t>Excellent! / You read that!</a:t>
-            </a:r>
-          </a:p>
-          <a:p/>
-          <a:p>
-            <a:r>
-              <a:t>EASIER OPTION:</a:t>
-            </a:r>
-          </a:p>
-          <a:p>
-            <a:r>
-              <a:t>Repeat after me.</a:t>
-            </a:r>
-          </a:p>
-          <a:p/>
-          <a:p>
-            <a:r>
-              <a:t>HARDER OPTION:</a:t>
-            </a:r>
-          </a:p>
-          <a:p>
-            <a:r>
-              <a:t>Child reads alone.</a:t>
-            </a:r>
-          </a:p>
-          <a:p/>
-          <a:p>
-            <a:r>
-              <a:t>TIMING: 12–13 min</a:t>
-            </a:r>
-          </a:p>
         </p:txBody>
       </p:sp>
       <p:sp>
@@ -1241,88 +858,7 @@
         <p:txBody>
           <a:bodyPr/>
           <a:lstStyle/>
-          <a:p>
-            <a:r>
-              <a:t>WHAT TO SAY:</a:t>
-            </a:r>
-          </a:p>
-          <a:p>
-            <a:r>
-              <a:t>One sentence at a time. Big praise!</a:t>
-            </a:r>
-          </a:p>
           <a:p/>
-          <a:p>
-            <a:r>
-              <a:t>QUESTION TO ASK:</a:t>
-            </a:r>
-          </a:p>
-          <a:p>
-            <a:r>
-              <a:t>Read one line.</a:t>
-            </a:r>
-          </a:p>
-          <a:p/>
-          <a:p>
-            <a:r>
-              <a:t>EXPECTED ANSWER:</a:t>
-            </a:r>
-          </a:p>
-          <a:p>
-            <a:r>
-              <a:t>Child reads with finger tracking.</a:t>
-            </a:r>
-          </a:p>
-          <a:p/>
-          <a:p>
-            <a:r>
-              <a:t>IF CHILD STRUGGLES:</a:t>
-            </a:r>
-          </a:p>
-          <a:p>
-            <a:r>
-              <a:t>Echo read together.</a:t>
-            </a:r>
-          </a:p>
-          <a:p/>
-          <a:p>
-            <a:r>
-              <a:t>ENCOURAGING PHRASES:</a:t>
-            </a:r>
-          </a:p>
-          <a:p>
-            <a:r>
-              <a:t>Excellent! / You read that!</a:t>
-            </a:r>
-          </a:p>
-          <a:p/>
-          <a:p>
-            <a:r>
-              <a:t>EASIER OPTION:</a:t>
-            </a:r>
-          </a:p>
-          <a:p>
-            <a:r>
-              <a:t>Repeat after me.</a:t>
-            </a:r>
-          </a:p>
-          <a:p/>
-          <a:p>
-            <a:r>
-              <a:t>HARDER OPTION:</a:t>
-            </a:r>
-          </a:p>
-          <a:p>
-            <a:r>
-              <a:t>Child reads alone.</a:t>
-            </a:r>
-          </a:p>
-          <a:p/>
-          <a:p>
-            <a:r>
-              <a:t>TIMING: 13–14 min</a:t>
-            </a:r>
-          </a:p>
         </p:txBody>
       </p:sp>
       <p:sp>
@@ -1388,88 +924,7 @@
         <p:txBody>
           <a:bodyPr/>
           <a:lstStyle/>
-          <a:p>
-            <a:r>
-              <a:t>WHAT TO SAY:</a:t>
-            </a:r>
-          </a:p>
-          <a:p>
-            <a:r>
-              <a:t>One sentence at a time. Big praise!</a:t>
-            </a:r>
-          </a:p>
           <a:p/>
-          <a:p>
-            <a:r>
-              <a:t>QUESTION TO ASK:</a:t>
-            </a:r>
-          </a:p>
-          <a:p>
-            <a:r>
-              <a:t>Read one line.</a:t>
-            </a:r>
-          </a:p>
-          <a:p/>
-          <a:p>
-            <a:r>
-              <a:t>EXPECTED ANSWER:</a:t>
-            </a:r>
-          </a:p>
-          <a:p>
-            <a:r>
-              <a:t>Child reads with finger tracking.</a:t>
-            </a:r>
-          </a:p>
-          <a:p/>
-          <a:p>
-            <a:r>
-              <a:t>IF CHILD STRUGGLES:</a:t>
-            </a:r>
-          </a:p>
-          <a:p>
-            <a:r>
-              <a:t>Echo read together.</a:t>
-            </a:r>
-          </a:p>
-          <a:p/>
-          <a:p>
-            <a:r>
-              <a:t>ENCOURAGING PHRASES:</a:t>
-            </a:r>
-          </a:p>
-          <a:p>
-            <a:r>
-              <a:t>Excellent! / You read that!</a:t>
-            </a:r>
-          </a:p>
-          <a:p/>
-          <a:p>
-            <a:r>
-              <a:t>EASIER OPTION:</a:t>
-            </a:r>
-          </a:p>
-          <a:p>
-            <a:r>
-              <a:t>Repeat after me.</a:t>
-            </a:r>
-          </a:p>
-          <a:p/>
-          <a:p>
-            <a:r>
-              <a:t>HARDER OPTION:</a:t>
-            </a:r>
-          </a:p>
-          <a:p>
-            <a:r>
-              <a:t>Child reads alone.</a:t>
-            </a:r>
-          </a:p>
-          <a:p/>
-          <a:p>
-            <a:r>
-              <a:t>TIMING: 14–15 min</a:t>
-            </a:r>
-          </a:p>
         </p:txBody>
       </p:sp>
       <p:sp>
@@ -1535,88 +990,7 @@
         <p:txBody>
           <a:bodyPr/>
           <a:lstStyle/>
-          <a:p>
-            <a:r>
-              <a:t>WHAT TO SAY:</a:t>
-            </a:r>
-          </a:p>
-          <a:p>
-            <a:r>
-              <a:t>One sentence at a time. Big praise!</a:t>
-            </a:r>
-          </a:p>
           <a:p/>
-          <a:p>
-            <a:r>
-              <a:t>QUESTION TO ASK:</a:t>
-            </a:r>
-          </a:p>
-          <a:p>
-            <a:r>
-              <a:t>Read one line.</a:t>
-            </a:r>
-          </a:p>
-          <a:p/>
-          <a:p>
-            <a:r>
-              <a:t>EXPECTED ANSWER:</a:t>
-            </a:r>
-          </a:p>
-          <a:p>
-            <a:r>
-              <a:t>Child reads with finger tracking.</a:t>
-            </a:r>
-          </a:p>
-          <a:p/>
-          <a:p>
-            <a:r>
-              <a:t>IF CHILD STRUGGLES:</a:t>
-            </a:r>
-          </a:p>
-          <a:p>
-            <a:r>
-              <a:t>Echo read together.</a:t>
-            </a:r>
-          </a:p>
-          <a:p/>
-          <a:p>
-            <a:r>
-              <a:t>ENCOURAGING PHRASES:</a:t>
-            </a:r>
-          </a:p>
-          <a:p>
-            <a:r>
-              <a:t>Excellent! / You read that!</a:t>
-            </a:r>
-          </a:p>
-          <a:p/>
-          <a:p>
-            <a:r>
-              <a:t>EASIER OPTION:</a:t>
-            </a:r>
-          </a:p>
-          <a:p>
-            <a:r>
-              <a:t>Repeat after me.</a:t>
-            </a:r>
-          </a:p>
-          <a:p/>
-          <a:p>
-            <a:r>
-              <a:t>HARDER OPTION:</a:t>
-            </a:r>
-          </a:p>
-          <a:p>
-            <a:r>
-              <a:t>Child reads alone.</a:t>
-            </a:r>
-          </a:p>
-          <a:p/>
-          <a:p>
-            <a:r>
-              <a:t>TIMING: 15–16 min</a:t>
-            </a:r>
-          </a:p>
         </p:txBody>
       </p:sp>
       <p:sp>
@@ -1682,88 +1056,7 @@
         <p:txBody>
           <a:bodyPr/>
           <a:lstStyle/>
-          <a:p>
-            <a:r>
-              <a:t>WHAT TO SAY:</a:t>
-            </a:r>
-          </a:p>
-          <a:p>
-            <a:r>
-              <a:t>Point and read each word!</a:t>
-            </a:r>
-          </a:p>
           <a:p/>
-          <a:p>
-            <a:r>
-              <a:t>QUESTION TO ASK:</a:t>
-            </a:r>
-          </a:p>
-          <a:p>
-            <a:r>
-              <a:t>Read BEN</a:t>
-            </a:r>
-          </a:p>
-          <a:p/>
-          <a:p>
-            <a:r>
-              <a:t>EXPECTED ANSWER:</a:t>
-            </a:r>
-          </a:p>
-          <a:p>
-            <a:r>
-              <a:t>all story words</a:t>
-            </a:r>
-          </a:p>
-          <a:p/>
-          <a:p>
-            <a:r>
-              <a:t>IF CHILD STRUGGLES:</a:t>
-            </a:r>
-          </a:p>
-          <a:p>
-            <a:r>
-              <a:t>Together first.</a:t>
-            </a:r>
-          </a:p>
-          <a:p/>
-          <a:p>
-            <a:r>
-              <a:t>ENCOURAGING PHRASES:</a:t>
-            </a:r>
-          </a:p>
-          <a:p>
-            <a:r>
-              <a:t>Star for each!</a:t>
-            </a:r>
-          </a:p>
-          <a:p/>
-          <a:p>
-            <a:r>
-              <a:t>EASIER OPTION:</a:t>
-            </a:r>
-          </a:p>
-          <a:p>
-            <a:r>
-              <a:t>3 words only.</a:t>
-            </a:r>
-          </a:p>
-          <a:p/>
-          <a:p>
-            <a:r>
-              <a:t>HARDER OPTION:</a:t>
-            </a:r>
-          </a:p>
-          <a:p>
-            <a:r>
-              <a:t>Use in sentence.</a:t>
-            </a:r>
-          </a:p>
-          <a:p/>
-          <a:p>
-            <a:r>
-              <a:t>TIMING: 16–17 min</a:t>
-            </a:r>
-          </a:p>
         </p:txBody>
       </p:sp>
       <p:sp>
@@ -1829,88 +1122,7 @@
         <p:txBody>
           <a:bodyPr/>
           <a:lstStyle/>
-          <a:p>
-            <a:r>
-              <a:t>WHAT TO SAY:</a:t>
-            </a:r>
-          </a:p>
-          <a:p>
-            <a:r>
-              <a:t>Tap the word I say!</a:t>
-            </a:r>
-          </a:p>
           <a:p/>
-          <a:p>
-            <a:r>
-              <a:t>QUESTION TO ASK:</a:t>
-            </a:r>
-          </a:p>
-          <a:p>
-            <a:r>
-              <a:t>Find RABBIT</a:t>
-            </a:r>
-          </a:p>
-          <a:p/>
-          <a:p>
-            <a:r>
-              <a:t>EXPECTED ANSWER:</a:t>
-            </a:r>
-          </a:p>
-          <a:p>
-            <a:r>
-              <a:t>points correctly</a:t>
-            </a:r>
-          </a:p>
-          <a:p/>
-          <a:p>
-            <a:r>
-              <a:t>IF CHILD STRUGGLES:</a:t>
-            </a:r>
-          </a:p>
-          <a:p>
-            <a:r>
-              <a:t>First letter clue.</a:t>
-            </a:r>
-          </a:p>
-          <a:p/>
-          <a:p>
-            <a:r>
-              <a:t>ENCOURAGING PHRASES:</a:t>
-            </a:r>
-          </a:p>
-          <a:p>
-            <a:r>
-              <a:t>You found it!</a:t>
-            </a:r>
-          </a:p>
-          <a:p/>
-          <a:p>
-            <a:r>
-              <a:t>EASIER OPTION:</a:t>
-            </a:r>
-          </a:p>
-          <a:p>
-            <a:r>
-              <a:t>One word.</a:t>
-            </a:r>
-          </a:p>
-          <a:p/>
-          <a:p>
-            <a:r>
-              <a:t>HARDER OPTION:</a:t>
-            </a:r>
-          </a:p>
-          <a:p>
-            <a:r>
-              <a:t>Say in sentence.</a:t>
-            </a:r>
-          </a:p>
-          <a:p/>
-          <a:p>
-            <a:r>
-              <a:t>TIMING: 17–18 min</a:t>
-            </a:r>
-          </a:p>
         </p:txBody>
       </p:sp>
       <p:sp>
@@ -1976,88 +1188,7 @@
         <p:txBody>
           <a:bodyPr/>
           <a:lstStyle/>
-          <a:p>
-            <a:r>
-              <a:t>WHAT TO SAY:</a:t>
-            </a:r>
-          </a:p>
-          <a:p>
-            <a:r>
-              <a:t>Tap the word I say!</a:t>
-            </a:r>
-          </a:p>
           <a:p/>
-          <a:p>
-            <a:r>
-              <a:t>QUESTION TO ASK:</a:t>
-            </a:r>
-          </a:p>
-          <a:p>
-            <a:r>
-              <a:t>Find SUN</a:t>
-            </a:r>
-          </a:p>
-          <a:p/>
-          <a:p>
-            <a:r>
-              <a:t>EXPECTED ANSWER:</a:t>
-            </a:r>
-          </a:p>
-          <a:p>
-            <a:r>
-              <a:t>points correctly</a:t>
-            </a:r>
-          </a:p>
-          <a:p/>
-          <a:p>
-            <a:r>
-              <a:t>IF CHILD STRUGGLES:</a:t>
-            </a:r>
-          </a:p>
-          <a:p>
-            <a:r>
-              <a:t>First letter clue.</a:t>
-            </a:r>
-          </a:p>
-          <a:p/>
-          <a:p>
-            <a:r>
-              <a:t>ENCOURAGING PHRASES:</a:t>
-            </a:r>
-          </a:p>
-          <a:p>
-            <a:r>
-              <a:t>You found it!</a:t>
-            </a:r>
-          </a:p>
-          <a:p/>
-          <a:p>
-            <a:r>
-              <a:t>EASIER OPTION:</a:t>
-            </a:r>
-          </a:p>
-          <a:p>
-            <a:r>
-              <a:t>One word.</a:t>
-            </a:r>
-          </a:p>
-          <a:p/>
-          <a:p>
-            <a:r>
-              <a:t>HARDER OPTION:</a:t>
-            </a:r>
-          </a:p>
-          <a:p>
-            <a:r>
-              <a:t>Say in sentence.</a:t>
-            </a:r>
-          </a:p>
-          <a:p/>
-          <a:p>
-            <a:r>
-              <a:t>TIMING: 18–19 min</a:t>
-            </a:r>
-          </a:p>
         </p:txBody>
       </p:sp>
       <p:sp>
@@ -2123,88 +1254,7 @@
         <p:txBody>
           <a:bodyPr/>
           <a:lstStyle/>
-          <a:p>
-            <a:r>
-              <a:t>WHAT TO SAY:</a:t>
-            </a:r>
-          </a:p>
-          <a:p>
-            <a:r>
-              <a:t>Point to one face!</a:t>
-            </a:r>
-          </a:p>
           <a:p/>
-          <a:p>
-            <a:r>
-              <a:t>QUESTION TO ASK:</a:t>
-            </a:r>
-          </a:p>
-          <a:p>
-            <a:r>
-              <a:t>How do you feel?</a:t>
-            </a:r>
-          </a:p>
-          <a:p/>
-          <a:p>
-            <a:r>
-              <a:t>EXPECTED ANSWER:</a:t>
-            </a:r>
-          </a:p>
-          <a:p>
-            <a:r>
-              <a:t>happy/sleepy/excited</a:t>
-            </a:r>
-          </a:p>
-          <a:p/>
-          <a:p>
-            <a:r>
-              <a:t>IF CHILD STRUGGLES:</a:t>
-            </a:r>
-          </a:p>
-          <a:p>
-            <a:r>
-              <a:t>Model first.</a:t>
-            </a:r>
-          </a:p>
-          <a:p/>
-          <a:p>
-            <a:r>
-              <a:t>ENCOURAGING PHRASES:</a:t>
-            </a:r>
-          </a:p>
-          <a:p>
-            <a:r>
-              <a:t>Great choice!</a:t>
-            </a:r>
-          </a:p>
-          <a:p/>
-          <a:p>
-            <a:r>
-              <a:t>EASIER OPTION:</a:t>
-            </a:r>
-          </a:p>
-          <a:p>
-            <a:r>
-              <a:t>Teacher picks first.</a:t>
-            </a:r>
-          </a:p>
-          <a:p/>
-          <a:p>
-            <a:r>
-              <a:t>HARDER OPTION:</a:t>
-            </a:r>
-          </a:p>
-          <a:p>
-            <a:r>
-              <a:t>Why?</a:t>
-            </a:r>
-          </a:p>
-          <a:p/>
-          <a:p>
-            <a:r>
-              <a:t>TIMING: 2–3 min</a:t>
-            </a:r>
-          </a:p>
         </p:txBody>
       </p:sp>
       <p:sp>
@@ -2270,88 +1320,7 @@
         <p:txBody>
           <a:bodyPr/>
           <a:lstStyle/>
-          <a:p>
-            <a:r>
-              <a:t>WHAT TO SAY:</a:t>
-            </a:r>
-          </a:p>
-          <a:p>
-            <a:r>
-              <a:t>Point to your answer!</a:t>
-            </a:r>
-          </a:p>
           <a:p/>
-          <a:p>
-            <a:r>
-              <a:t>QUESTION TO ASK:</a:t>
-            </a:r>
-          </a:p>
-          <a:p>
-            <a:r>
-              <a:t>Who? Where?</a:t>
-            </a:r>
-          </a:p>
-          <a:p/>
-          <a:p>
-            <a:r>
-              <a:t>EXPECTED ANSWER:</a:t>
-            </a:r>
-          </a:p>
-          <a:p>
-            <a:r>
-              <a:t>Rabbit; near a tree</a:t>
-            </a:r>
-          </a:p>
-          <a:p/>
-          <a:p>
-            <a:r>
-              <a:t>IF CHILD STRUGGLES:</a:t>
-            </a:r>
-          </a:p>
-          <a:p>
-            <a:r>
-              <a:t>Picture help.</a:t>
-            </a:r>
-          </a:p>
-          <a:p/>
-          <a:p>
-            <a:r>
-              <a:t>ENCOURAGING PHRASES:</a:t>
-            </a:r>
-          </a:p>
-          <a:p>
-            <a:r>
-              <a:t>Yes!</a:t>
-            </a:r>
-          </a:p>
-          <a:p/>
-          <a:p>
-            <a:r>
-              <a:t>EASIER OPTION:</a:t>
-            </a:r>
-          </a:p>
-          <a:p>
-            <a:r>
-              <a:t>Yes/no.</a:t>
-            </a:r>
-          </a:p>
-          <a:p/>
-          <a:p>
-            <a:r>
-              <a:t>HARDER OPTION:</a:t>
-            </a:r>
-          </a:p>
-          <a:p>
-            <a:r>
-              <a:t>What color ball?</a:t>
-            </a:r>
-          </a:p>
-          <a:p/>
-          <a:p>
-            <a:r>
-              <a:t>TIMING: 19–20 min</a:t>
-            </a:r>
-          </a:p>
         </p:txBody>
       </p:sp>
       <p:sp>
@@ -2417,88 +1386,7 @@
         <p:txBody>
           <a:bodyPr/>
           <a:lstStyle/>
-          <a:p>
-            <a:r>
-              <a:t>WHAT TO SAY:</a:t>
-            </a:r>
-          </a:p>
-          <a:p>
-            <a:r>
-              <a:t>Point to answer!</a:t>
-            </a:r>
-          </a:p>
           <a:p/>
-          <a:p>
-            <a:r>
-              <a:t>QUESTION TO ASK:</a:t>
-            </a:r>
-          </a:p>
-          <a:p>
-            <a:r>
-              <a:t>What? Ball? Happy?</a:t>
-            </a:r>
-          </a:p>
-          <a:p/>
-          <a:p>
-            <a:r>
-              <a:t>EXPECTED ANSWER:</a:t>
-            </a:r>
-          </a:p>
-          <a:p>
-            <a:r>
-              <a:t>ball; rolls away; yes</a:t>
-            </a:r>
-          </a:p>
-          <a:p/>
-          <a:p>
-            <a:r>
-              <a:t>IF CHILD STRUGGLES:</a:t>
-            </a:r>
-          </a:p>
-          <a:p>
-            <a:r>
-              <a:t>Look at story slides.</a:t>
-            </a:r>
-          </a:p>
-          <a:p/>
-          <a:p>
-            <a:r>
-              <a:t>ENCOURAGING PHRASES:</a:t>
-            </a:r>
-          </a:p>
-          <a:p>
-            <a:r>
-              <a:t>Smart!</a:t>
-            </a:r>
-          </a:p>
-          <a:p/>
-          <a:p>
-            <a:r>
-              <a:t>EASIER OPTION:</a:t>
-            </a:r>
-          </a:p>
-          <a:p>
-            <a:r>
-              <a:t>Two choices.</a:t>
-            </a:r>
-          </a:p>
-          <a:p/>
-          <a:p>
-            <a:r>
-              <a:t>HARDER OPTION:</a:t>
-            </a:r>
-          </a:p>
-          <a:p>
-            <a:r>
-              <a:t>Tell me more.</a:t>
-            </a:r>
-          </a:p>
-          <a:p/>
-          <a:p>
-            <a:r>
-              <a:t>TIMING: 20–22 min</a:t>
-            </a:r>
-          </a:p>
         </p:txBody>
       </p:sp>
       <p:sp>
@@ -2564,88 +1452,7 @@
         <p:txBody>
           <a:bodyPr/>
           <a:lstStyle/>
-          <a:p>
-            <a:r>
-              <a:t>WHAT TO SAY:</a:t>
-            </a:r>
-          </a:p>
-          <a:p>
-            <a:r>
-              <a:t>Say the whole sentence!</a:t>
-            </a:r>
-          </a:p>
           <a:p/>
-          <a:p>
-            <a:r>
-              <a:t>QUESTION TO ASK:</a:t>
-            </a:r>
-          </a:p>
-          <a:p>
-            <a:r>
-              <a:t>The rabbit can ___?</a:t>
-            </a:r>
-          </a:p>
-          <a:p/>
-          <a:p>
-            <a:r>
-              <a:t>EXPECTED ANSWER:</a:t>
-            </a:r>
-          </a:p>
-          <a:p>
-            <a:r>
-              <a:t>run; red; rabbit</a:t>
-            </a:r>
-          </a:p>
-          <a:p/>
-          <a:p>
-            <a:r>
-              <a:t>IF CHILD STRUGGLES:</a:t>
-            </a:r>
-          </a:p>
-          <a:p>
-            <a:r>
-              <a:t>Say together first.</a:t>
-            </a:r>
-          </a:p>
-          <a:p/>
-          <a:p>
-            <a:r>
-              <a:t>ENCOURAGING PHRASES:</a:t>
-            </a:r>
-          </a:p>
-          <a:p>
-            <a:r>
-              <a:t>Wonderful!</a:t>
-            </a:r>
-          </a:p>
-          <a:p/>
-          <a:p>
-            <a:r>
-              <a:t>EASIER OPTION:</a:t>
-            </a:r>
-          </a:p>
-          <a:p>
-            <a:r>
-              <a:t>Point to answer.</a:t>
-            </a:r>
-          </a:p>
-          <a:p/>
-          <a:p>
-            <a:r>
-              <a:t>HARDER OPTION:</a:t>
-            </a:r>
-          </a:p>
-          <a:p>
-            <a:r>
-              <a:t>New sentence.</a:t>
-            </a:r>
-          </a:p>
-          <a:p/>
-          <a:p>
-            <a:r>
-              <a:t>TIMING: 22–23 min</a:t>
-            </a:r>
-          </a:p>
         </p:txBody>
       </p:sp>
       <p:sp>
@@ -2711,88 +1518,7 @@
         <p:txBody>
           <a:bodyPr/>
           <a:lstStyle/>
-          <a:p>
-            <a:r>
-              <a:t>WHAT TO SAY:</a:t>
-            </a:r>
-          </a:p>
-          <a:p>
-            <a:r>
-              <a:t>Words that sound alike!</a:t>
-            </a:r>
-          </a:p>
           <a:p/>
-          <a:p>
-            <a:r>
-              <a:t>QUESTION TO ASK:</a:t>
-            </a:r>
-          </a:p>
-          <a:p>
-            <a:r>
-              <a:t>What rhymes with run?</a:t>
-            </a:r>
-          </a:p>
-          <a:p/>
-          <a:p>
-            <a:r>
-              <a:t>EXPECTED ANSWER:</a:t>
-            </a:r>
-          </a:p>
-          <a:p>
-            <a:r>
-              <a:t>sun</a:t>
-            </a:r>
-          </a:p>
-          <a:p/>
-          <a:p>
-            <a:r>
-              <a:t>IF CHILD STRUGGLES:</a:t>
-            </a:r>
-          </a:p>
-          <a:p>
-            <a:r>
-              <a:t>Hum the sounds.</a:t>
-            </a:r>
-          </a:p>
-          <a:p/>
-          <a:p>
-            <a:r>
-              <a:t>ENCOURAGING PHRASES:</a:t>
-            </a:r>
-          </a:p>
-          <a:p>
-            <a:r>
-              <a:t>Great ears!</a:t>
-            </a:r>
-          </a:p>
-          <a:p/>
-          <a:p>
-            <a:r>
-              <a:t>EASIER OPTION:</a:t>
-            </a:r>
-          </a:p>
-          <a:p>
-            <a:r>
-              <a:t>Clap syllables.</a:t>
-            </a:r>
-          </a:p>
-          <a:p/>
-          <a:p>
-            <a:r>
-              <a:t>HARDER OPTION:</a:t>
-            </a:r>
-          </a:p>
-          <a:p>
-            <a:r>
-              <a:t>Find another rhyme.</a:t>
-            </a:r>
-          </a:p>
-          <a:p/>
-          <a:p>
-            <a:r>
-              <a:t>TIMING: 23–24 min</a:t>
-            </a:r>
-          </a:p>
         </p:txBody>
       </p:sp>
       <p:sp>
@@ -2858,88 +1584,7 @@
         <p:txBody>
           <a:bodyPr/>
           <a:lstStyle/>
-          <a:p>
-            <a:r>
-              <a:t>WHAT TO SAY:</a:t>
-            </a:r>
-          </a:p>
-          <a:p>
-            <a:r>
-              <a:t>Quick seated wiggle!</a:t>
-            </a:r>
-          </a:p>
           <a:p/>
-          <a:p>
-            <a:r>
-              <a:t>QUESTION TO ASK:</a:t>
-            </a:r>
-          </a:p>
-          <a:p>
-            <a:r>
-              <a:t>Can you do all four?</a:t>
-            </a:r>
-          </a:p>
-          <a:p/>
-          <a:p>
-            <a:r>
-              <a:t>EXPECTED ANSWER:</a:t>
-            </a:r>
-          </a:p>
-          <a:p>
-            <a:r>
-              <a:t>follows moves</a:t>
-            </a:r>
-          </a:p>
-          <a:p/>
-          <a:p>
-            <a:r>
-              <a:t>IF CHILD STRUGGLES:</a:t>
-            </a:r>
-          </a:p>
-          <a:p>
-            <a:r>
-              <a:t>Do with child.</a:t>
-            </a:r>
-          </a:p>
-          <a:p/>
-          <a:p>
-            <a:r>
-              <a:t>ENCOURAGING PHRASES:</a:t>
-            </a:r>
-          </a:p>
-          <a:p>
-            <a:r>
-              <a:t>Fun!</a:t>
-            </a:r>
-          </a:p>
-          <a:p/>
-          <a:p>
-            <a:r>
-              <a:t>EASIER OPTION:</a:t>
-            </a:r>
-          </a:p>
-          <a:p>
-            <a:r>
-              <a:t>One move.</a:t>
-            </a:r>
-          </a:p>
-          <a:p/>
-          <a:p>
-            <a:r>
-              <a:t>HARDER OPTION:</a:t>
-            </a:r>
-          </a:p>
-          <a:p>
-            <a:r>
-              <a:t>Favorite move?</a:t>
-            </a:r>
-          </a:p>
-          <a:p/>
-          <a:p>
-            <a:r>
-              <a:t>TIMING: 24 min</a:t>
-            </a:r>
-          </a:p>
         </p:txBody>
       </p:sp>
       <p:sp>
@@ -3005,88 +1650,7 @@
         <p:txBody>
           <a:bodyPr/>
           <a:lstStyle/>
-          <a:p>
-            <a:r>
-              <a:t>WHAT TO SAY:</a:t>
-            </a:r>
-          </a:p>
-          <a:p>
-            <a:r>
-              <a:t>Your mini-story!</a:t>
-            </a:r>
-          </a:p>
           <a:p/>
-          <a:p>
-            <a:r>
-              <a:t>QUESTION TO ASK:</a:t>
-            </a:r>
-          </a:p>
-          <a:p>
-            <a:r>
-              <a:t>Who? Where? What?</a:t>
-            </a:r>
-          </a:p>
-          <a:p/>
-          <a:p>
-            <a:r>
-              <a:t>EXPECTED ANSWER:</a:t>
-            </a:r>
-          </a:p>
-          <a:p>
-            <a:r>
-              <a:t>any simple story</a:t>
-            </a:r>
-          </a:p>
-          <a:p/>
-          <a:p>
-            <a:r>
-              <a:t>IF CHILD STRUGGLES:</a:t>
-            </a:r>
-          </a:p>
-          <a:p>
-            <a:r>
-              <a:t>Praise ideas not grammar.</a:t>
-            </a:r>
-          </a:p>
-          <a:p/>
-          <a:p>
-            <a:r>
-              <a:t>ENCOURAGING PHRASES:</a:t>
-            </a:r>
-          </a:p>
-          <a:p>
-            <a:r>
-              <a:t>I love it!</a:t>
-            </a:r>
-          </a:p>
-          <a:p/>
-          <a:p>
-            <a:r>
-              <a:t>EASIER OPTION:</a:t>
-            </a:r>
-          </a:p>
-          <a:p>
-            <a:r>
-              <a:t>One sentence.</a:t>
-            </a:r>
-          </a:p>
-          <a:p/>
-          <a:p>
-            <a:r>
-              <a:t>HARDER OPTION:</a:t>
-            </a:r>
-          </a:p>
-          <a:p>
-            <a:r>
-              <a:t>What happens next?</a:t>
-            </a:r>
-          </a:p>
-          <a:p/>
-          <a:p>
-            <a:r>
-              <a:t>TIMING: 24–26 min</a:t>
-            </a:r>
-          </a:p>
         </p:txBody>
       </p:sp>
       <p:sp>
@@ -3152,88 +1716,7 @@
         <p:txBody>
           <a:bodyPr/>
           <a:lstStyle/>
-          <a:p>
-            <a:r>
-              <a:t>WHAT TO SAY:</a:t>
-            </a:r>
-          </a:p>
-          <a:p>
-            <a:r>
-              <a:t>Read and earn stars!</a:t>
-            </a:r>
-          </a:p>
           <a:p/>
-          <a:p>
-            <a:r>
-              <a:t>QUESTION TO ASK:</a:t>
-            </a:r>
-          </a:p>
-          <a:p>
-            <a:r>
-              <a:t>Read each line.</a:t>
-            </a:r>
-          </a:p>
-          <a:p/>
-          <a:p>
-            <a:r>
-              <a:t>EXPECTED ANSWER:</a:t>
-            </a:r>
-          </a:p>
-          <a:p>
-            <a:r>
-              <a:t>reads with help</a:t>
-            </a:r>
-          </a:p>
-          <a:p/>
-          <a:p>
-            <a:r>
-              <a:t>IF CHILD STRUGGLES:</a:t>
-            </a:r>
-          </a:p>
-          <a:p>
-            <a:r>
-              <a:t>Together on hard words.</a:t>
-            </a:r>
-          </a:p>
-          <a:p/>
-          <a:p>
-            <a:r>
-              <a:t>ENCOURAGING PHRASES:</a:t>
-            </a:r>
-          </a:p>
-          <a:p>
-            <a:r>
-              <a:t>Star for you!</a:t>
-            </a:r>
-          </a:p>
-          <a:p/>
-          <a:p>
-            <a:r>
-              <a:t>EASIER OPTION:</a:t>
-            </a:r>
-          </a:p>
-          <a:p>
-            <a:r>
-              <a:t>One sentence.</a:t>
-            </a:r>
-          </a:p>
-          <a:p/>
-          <a:p>
-            <a:r>
-              <a:t>HARDER OPTION:</a:t>
-            </a:r>
-          </a:p>
-          <a:p>
-            <a:r>
-              <a:t>All alone.</a:t>
-            </a:r>
-          </a:p>
-          <a:p/>
-          <a:p>
-            <a:r>
-              <a:t>TIMING: 26–27 min</a:t>
-            </a:r>
-          </a:p>
         </p:txBody>
       </p:sp>
       <p:sp>
@@ -3299,88 +1782,7 @@
         <p:txBody>
           <a:bodyPr/>
           <a:lstStyle/>
-          <a:p>
-            <a:r>
-              <a:t>WHAT TO SAY:</a:t>
-            </a:r>
-          </a:p>
-          <a:p>
-            <a:r>
-              <a:t>Read and earn stars!</a:t>
-            </a:r>
-          </a:p>
           <a:p/>
-          <a:p>
-            <a:r>
-              <a:t>QUESTION TO ASK:</a:t>
-            </a:r>
-          </a:p>
-          <a:p>
-            <a:r>
-              <a:t>Read each line.</a:t>
-            </a:r>
-          </a:p>
-          <a:p/>
-          <a:p>
-            <a:r>
-              <a:t>EXPECTED ANSWER:</a:t>
-            </a:r>
-          </a:p>
-          <a:p>
-            <a:r>
-              <a:t>reads with help</a:t>
-            </a:r>
-          </a:p>
-          <a:p/>
-          <a:p>
-            <a:r>
-              <a:t>IF CHILD STRUGGLES:</a:t>
-            </a:r>
-          </a:p>
-          <a:p>
-            <a:r>
-              <a:t>Together on hard words.</a:t>
-            </a:r>
-          </a:p>
-          <a:p/>
-          <a:p>
-            <a:r>
-              <a:t>ENCOURAGING PHRASES:</a:t>
-            </a:r>
-          </a:p>
-          <a:p>
-            <a:r>
-              <a:t>Star for you!</a:t>
-            </a:r>
-          </a:p>
-          <a:p/>
-          <a:p>
-            <a:r>
-              <a:t>EASIER OPTION:</a:t>
-            </a:r>
-          </a:p>
-          <a:p>
-            <a:r>
-              <a:t>One sentence.</a:t>
-            </a:r>
-          </a:p>
-          <a:p/>
-          <a:p>
-            <a:r>
-              <a:t>HARDER OPTION:</a:t>
-            </a:r>
-          </a:p>
-          <a:p>
-            <a:r>
-              <a:t>All alone.</a:t>
-            </a:r>
-          </a:p>
-          <a:p/>
-          <a:p>
-            <a:r>
-              <a:t>TIMING: 27–28 min</a:t>
-            </a:r>
-          </a:p>
         </p:txBody>
       </p:sp>
       <p:sp>
@@ -3446,88 +1848,7 @@
         <p:txBody>
           <a:bodyPr/>
           <a:lstStyle/>
-          <a:p>
-            <a:r>
-              <a:t>WHAT TO SAY:</a:t>
-            </a:r>
-          </a:p>
-          <a:p>
-            <a:r>
-              <a:t>Remember our adventure!</a:t>
-            </a:r>
-          </a:p>
           <a:p/>
-          <a:p>
-            <a:r>
-              <a:t>QUESTION TO ASK:</a:t>
-            </a:r>
-          </a:p>
-          <a:p>
-            <a:r>
-              <a:t>Four questions.</a:t>
-            </a:r>
-          </a:p>
-          <a:p/>
-          <a:p>
-            <a:r>
-              <a:t>EXPECTED ANSWER:</a:t>
-            </a:r>
-          </a:p>
-          <a:p>
-            <a:r>
-              <a:t>Ben; ball rolled; etc.</a:t>
-            </a:r>
-          </a:p>
-          <a:p/>
-          <a:p>
-            <a:r>
-              <a:t>IF CHILD STRUGGLES:</a:t>
-            </a:r>
-          </a:p>
-          <a:p>
-            <a:r>
-              <a:t>Choices OK.</a:t>
-            </a:r>
-          </a:p>
-          <a:p/>
-          <a:p>
-            <a:r>
-              <a:t>ENCOURAGING PHRASES:</a:t>
-            </a:r>
-          </a:p>
-          <a:p>
-            <a:r>
-              <a:t>Great memory!</a:t>
-            </a:r>
-          </a:p>
-          <a:p/>
-          <a:p>
-            <a:r>
-              <a:t>EASIER OPTION:</a:t>
-            </a:r>
-          </a:p>
-          <a:p>
-            <a:r>
-              <a:t>Nod.</a:t>
-            </a:r>
-          </a:p>
-          <a:p/>
-          <a:p>
-            <a:r>
-              <a:t>HARDER OPTION:</a:t>
-            </a:r>
-          </a:p>
-          <a:p>
-            <a:r>
-              <a:t>Favorite part?</a:t>
-            </a:r>
-          </a:p>
-          <a:p/>
-          <a:p>
-            <a:r>
-              <a:t>TIMING: 28–29 min</a:t>
-            </a:r>
-          </a:p>
         </p:txBody>
       </p:sp>
       <p:sp>
@@ -3593,88 +1914,7 @@
         <p:txBody>
           <a:bodyPr/>
           <a:lstStyle/>
-          <a:p>
-            <a:r>
-              <a:t>WHAT TO SAY:</a:t>
-            </a:r>
-          </a:p>
-          <a:p>
-            <a:r>
-              <a:t>Big celebration!</a:t>
-            </a:r>
-          </a:p>
           <a:p/>
-          <a:p>
-            <a:r>
-              <a:t>QUESTION TO ASK:</a:t>
-            </a:r>
-          </a:p>
-          <a:p>
-            <a:r>
-              <a:t>Favorite part?</a:t>
-            </a:r>
-          </a:p>
-          <a:p/>
-          <a:p>
-            <a:r>
-              <a:t>EXPECTED ANSWER:</a:t>
-            </a:r>
-          </a:p>
-          <a:p>
-            <a:r>
-              <a:t>any happy answer</a:t>
-            </a:r>
-          </a:p>
-          <a:p/>
-          <a:p>
-            <a:r>
-              <a:t>IF CHILD STRUGGLES:</a:t>
-            </a:r>
-          </a:p>
-          <a:p>
-            <a:r>
-              <a:t>End high energy.</a:t>
-            </a:r>
-          </a:p>
-          <a:p/>
-          <a:p>
-            <a:r>
-              <a:t>ENCOURAGING PHRASES:</a:t>
-            </a:r>
-          </a:p>
-          <a:p>
-            <a:r>
-              <a:t>So proud!</a:t>
-            </a:r>
-          </a:p>
-          <a:p/>
-          <a:p>
-            <a:r>
-              <a:t>EASIER OPTION:</a:t>
-            </a:r>
-          </a:p>
-          <a:p>
-            <a:r>
-              <a:t>Virtual sticker.</a:t>
-            </a:r>
-          </a:p>
-          <a:p/>
-          <a:p>
-            <a:r>
-              <a:t>HARDER OPTION:</a:t>
-            </a:r>
-          </a:p>
-          <a:p>
-            <a:r>
-              <a:t>See you next time!</a:t>
-            </a:r>
-          </a:p>
-          <a:p/>
-          <a:p>
-            <a:r>
-              <a:t>TIMING: 29–30 min</a:t>
-            </a:r>
-          </a:p>
         </p:txBody>
       </p:sp>
       <p:sp>
@@ -3740,88 +1980,7 @@
         <p:txBody>
           <a:bodyPr/>
           <a:lstStyle/>
-          <a:p>
-            <a:r>
-              <a:t>WHAT TO SAY:</a:t>
-            </a:r>
-          </a:p>
-          <a:p>
-            <a:r>
-              <a:t>We will do four fun things!</a:t>
-            </a:r>
-          </a:p>
           <a:p/>
-          <a:p>
-            <a:r>
-              <a:t>QUESTION TO ASK:</a:t>
-            </a:r>
-          </a:p>
-          <a:p>
-            <a:r>
-              <a:t>Which sounds most fun?</a:t>
-            </a:r>
-          </a:p>
-          <a:p/>
-          <a:p>
-            <a:r>
-              <a:t>EXPECTED ANSWER:</a:t>
-            </a:r>
-          </a:p>
-          <a:p>
-            <a:r>
-              <a:t>any choice</a:t>
-            </a:r>
-          </a:p>
-          <a:p/>
-          <a:p>
-            <a:r>
-              <a:t>IF CHILD STRUGGLES:</a:t>
-            </a:r>
-          </a:p>
-          <a:p>
-            <a:r>
-              <a:t>Keep it exciting.</a:t>
-            </a:r>
-          </a:p>
-          <a:p/>
-          <a:p>
-            <a:r>
-              <a:t>ENCOURAGING PHRASES:</a:t>
-            </a:r>
-          </a:p>
-          <a:p>
-            <a:r>
-              <a:t>Me too!</a:t>
-            </a:r>
-          </a:p>
-          <a:p/>
-          <a:p>
-            <a:r>
-              <a:t>EASIER OPTION:</a:t>
-            </a:r>
-          </a:p>
-          <a:p>
-            <a:r>
-              <a:t>Point to one.</a:t>
-            </a:r>
-          </a:p>
-          <a:p/>
-          <a:p>
-            <a:r>
-              <a:t>HARDER OPTION:</a:t>
-            </a:r>
-          </a:p>
-          <a:p>
-            <a:r>
-              <a:t>Let's go!</a:t>
-            </a:r>
-          </a:p>
-          <a:p/>
-          <a:p>
-            <a:r>
-              <a:t>TIMING: 3 min</a:t>
-            </a:r>
-          </a:p>
         </p:txBody>
       </p:sp>
       <p:sp>
@@ -3887,88 +2046,7 @@
         <p:txBody>
           <a:bodyPr/>
           <a:lstStyle/>
-          <a:p>
-            <a:r>
-              <a:t>WHAT TO SAY:</a:t>
-            </a:r>
-          </a:p>
-          <a:p>
-            <a:r>
-              <a:t>Look and say each word. Repeat each word.</a:t>
-            </a:r>
-          </a:p>
           <a:p/>
-          <a:p>
-            <a:r>
-              <a:t>QUESTION TO ASK:</a:t>
-            </a:r>
-          </a:p>
-          <a:p>
-            <a:r>
-              <a:t>What is this?</a:t>
-            </a:r>
-          </a:p>
-          <a:p/>
-          <a:p>
-            <a:r>
-              <a:t>EXPECTED ANSWER:</a:t>
-            </a:r>
-          </a:p>
-          <a:p>
-            <a:r>
-              <a:t>Rabbit, Tree, House</a:t>
-            </a:r>
-          </a:p>
-          <a:p/>
-          <a:p>
-            <a:r>
-              <a:t>IF CHILD STRUGGLES:</a:t>
-            </a:r>
-          </a:p>
-          <a:p>
-            <a:r>
-              <a:t>First sound help. Point to mouth.</a:t>
-            </a:r>
-          </a:p>
-          <a:p/>
-          <a:p>
-            <a:r>
-              <a:t>ENCOURAGING PHRASES:</a:t>
-            </a:r>
-          </a:p>
-          <a:p>
-            <a:r>
-              <a:t>Yes! / Say it with me! / Reading star!</a:t>
-            </a:r>
-          </a:p>
-          <a:p/>
-          <a:p>
-            <a:r>
-              <a:t>EASIER OPTION:</a:t>
-            </a:r>
-          </a:p>
-          <a:p>
-            <a:r>
-              <a:t>Repeat after teacher.</a:t>
-            </a:r>
-          </a:p>
-          <a:p/>
-          <a:p>
-            <a:r>
-              <a:t>HARDER OPTION:</a:t>
-            </a:r>
-          </a:p>
-          <a:p>
-            <a:r>
-              <a:t>Use in a sentence: I see a ___</a:t>
-            </a:r>
-          </a:p>
-          <a:p/>
-          <a:p>
-            <a:r>
-              <a:t>TIMING: 3–5 min</a:t>
-            </a:r>
-          </a:p>
         </p:txBody>
       </p:sp>
       <p:sp>
@@ -4034,88 +2112,7 @@
         <p:txBody>
           <a:bodyPr/>
           <a:lstStyle/>
-          <a:p>
-            <a:r>
-              <a:t>WHAT TO SAY:</a:t>
-            </a:r>
-          </a:p>
-          <a:p>
-            <a:r>
-              <a:t>Look and say each word. Ball is in our story!</a:t>
-            </a:r>
-          </a:p>
           <a:p/>
-          <a:p>
-            <a:r>
-              <a:t>QUESTION TO ASK:</a:t>
-            </a:r>
-          </a:p>
-          <a:p>
-            <a:r>
-              <a:t>What is this?</a:t>
-            </a:r>
-          </a:p>
-          <a:p/>
-          <a:p>
-            <a:r>
-              <a:t>EXPECTED ANSWER:</a:t>
-            </a:r>
-          </a:p>
-          <a:p>
-            <a:r>
-              <a:t>Sun, Apple, Ball</a:t>
-            </a:r>
-          </a:p>
-          <a:p/>
-          <a:p>
-            <a:r>
-              <a:t>IF CHILD STRUGGLES:</a:t>
-            </a:r>
-          </a:p>
-          <a:p>
-            <a:r>
-              <a:t>First sound help. Point to mouth.</a:t>
-            </a:r>
-          </a:p>
-          <a:p/>
-          <a:p>
-            <a:r>
-              <a:t>ENCOURAGING PHRASES:</a:t>
-            </a:r>
-          </a:p>
-          <a:p>
-            <a:r>
-              <a:t>Yes! / Say it with me! / Reading star!</a:t>
-            </a:r>
-          </a:p>
-          <a:p/>
-          <a:p>
-            <a:r>
-              <a:t>EASIER OPTION:</a:t>
-            </a:r>
-          </a:p>
-          <a:p>
-            <a:r>
-              <a:t>Repeat after teacher.</a:t>
-            </a:r>
-          </a:p>
-          <a:p/>
-          <a:p>
-            <a:r>
-              <a:t>HARDER OPTION:</a:t>
-            </a:r>
-          </a:p>
-          <a:p>
-            <a:r>
-              <a:t>Use in a sentence: I see a ___</a:t>
-            </a:r>
-          </a:p>
-          <a:p/>
-          <a:p>
-            <a:r>
-              <a:t>TIMING: 5–6 min</a:t>
-            </a:r>
-          </a:p>
         </p:txBody>
       </p:sp>
       <p:sp>
@@ -4181,88 +2178,7 @@
         <p:txBody>
           <a:bodyPr/>
           <a:lstStyle/>
-          <a:p>
-            <a:r>
-              <a:t>WHAT TO SAY:</a:t>
-            </a:r>
-          </a:p>
-          <a:p>
-            <a:r>
-              <a:t>Clap the sounds!</a:t>
-            </a:r>
-          </a:p>
           <a:p/>
-          <a:p>
-            <a:r>
-              <a:t>QUESTION TO ASK:</a:t>
-            </a:r>
-          </a:p>
-          <a:p>
-            <a:r>
-              <a:t>Say R-A-B-B-I-T</a:t>
-            </a:r>
-          </a:p>
-          <a:p/>
-          <a:p>
-            <a:r>
-              <a:t>EXPECTED ANSWER:</a:t>
-            </a:r>
-          </a:p>
-          <a:p>
-            <a:r>
-              <a:t>rabbit</a:t>
-            </a:r>
-          </a:p>
-          <a:p/>
-          <a:p>
-            <a:r>
-              <a:t>IF CHILD STRUGGLES:</a:t>
-            </a:r>
-          </a:p>
-          <a:p>
-            <a:r>
-              <a:t>Slow stretch.</a:t>
-            </a:r>
-          </a:p>
-          <a:p/>
-          <a:p>
-            <a:r>
-              <a:t>ENCOURAGING PHRASES:</a:t>
-            </a:r>
-          </a:p>
-          <a:p>
-            <a:r>
-              <a:t>Together!</a:t>
-            </a:r>
-          </a:p>
-          <a:p/>
-          <a:p>
-            <a:r>
-              <a:t>EASIER OPTION:</a:t>
-            </a:r>
-          </a:p>
-          <a:p>
-            <a:r>
-              <a:t>RRR sound.</a:t>
-            </a:r>
-          </a:p>
-          <a:p/>
-          <a:p>
-            <a:r>
-              <a:t>HARDER OPTION:</a:t>
-            </a:r>
-          </a:p>
-          <a:p>
-            <a:r>
-              <a:t>Tap desk.</a:t>
-            </a:r>
-          </a:p>
-          <a:p/>
-          <a:p>
-            <a:r>
-              <a:t>TIMING: 6–7 min</a:t>
-            </a:r>
-          </a:p>
         </p:txBody>
       </p:sp>
       <p:sp>
@@ -4328,88 +2244,7 @@
         <p:txBody>
           <a:bodyPr/>
           <a:lstStyle/>
-          <a:p>
-            <a:r>
-              <a:t>WHAT TO SAY:</a:t>
-            </a:r>
-          </a:p>
-          <a:p>
-            <a:r>
-              <a:t>Story words!</a:t>
-            </a:r>
-          </a:p>
           <a:p/>
-          <a:p>
-            <a:r>
-              <a:t>QUESTION TO ASK:</a:t>
-            </a:r>
-          </a:p>
-          <a:p>
-            <a:r>
-              <a:t>Say HOME</a:t>
-            </a:r>
-          </a:p>
-          <a:p/>
-          <a:p>
-            <a:r>
-              <a:t>EXPECTED ANSWER:</a:t>
-            </a:r>
-          </a:p>
-          <a:p>
-            <a:r>
-              <a:t>home, ball</a:t>
-            </a:r>
-          </a:p>
-          <a:p/>
-          <a:p>
-            <a:r>
-              <a:t>IF CHILD STRUGGLES:</a:t>
-            </a:r>
-          </a:p>
-          <a:p>
-            <a:r>
-              <a:t>Echo.</a:t>
-            </a:r>
-          </a:p>
-          <a:p/>
-          <a:p>
-            <a:r>
-              <a:t>ENCOURAGING PHRASES:</a:t>
-            </a:r>
-          </a:p>
-          <a:p>
-            <a:r>
-              <a:t>Super!</a:t>
-            </a:r>
-          </a:p>
-          <a:p/>
-          <a:p>
-            <a:r>
-              <a:t>EASIER OPTION:</a:t>
-            </a:r>
-          </a:p>
-          <a:p>
-            <a:r>
-              <a:t>First letter.</a:t>
-            </a:r>
-          </a:p>
-          <a:p/>
-          <a:p>
-            <a:r>
-              <a:t>HARDER OPTION:</a:t>
-            </a:r>
-          </a:p>
-          <a:p>
-            <a:r>
-              <a:t>Sentence.</a:t>
-            </a:r>
-          </a:p>
-          <a:p/>
-          <a:p>
-            <a:r>
-              <a:t>TIMING: 7–8 min</a:t>
-            </a:r>
-          </a:p>
         </p:txBody>
       </p:sp>
       <p:sp>
@@ -4475,88 +2310,7 @@
         <p:txBody>
           <a:bodyPr/>
           <a:lstStyle/>
-          <a:p>
-            <a:r>
-              <a:t>WHAT TO SAY:</a:t>
-            </a:r>
-          </a:p>
-          <a:p>
-            <a:r>
-              <a:t>Pick the story word!</a:t>
-            </a:r>
-          </a:p>
           <a:p/>
-          <a:p>
-            <a:r>
-              <a:t>QUESTION TO ASK:</a:t>
-            </a:r>
-          </a:p>
-          <a:p>
-            <a:r>
-              <a:t>Which one?</a:t>
-            </a:r>
-          </a:p>
-          <a:p/>
-          <a:p>
-            <a:r>
-              <a:t>EXPECTED ANSWER:</a:t>
-            </a:r>
-          </a:p>
-          <a:p>
-            <a:r>
-              <a:t>RUN</a:t>
-            </a:r>
-          </a:p>
-          <a:p/>
-          <a:p>
-            <a:r>
-              <a:t>IF CHILD STRUGGLES:</a:t>
-            </a:r>
-          </a:p>
-          <a:p>
-            <a:r>
-              <a:t>Say each aloud.</a:t>
-            </a:r>
-          </a:p>
-          <a:p/>
-          <a:p>
-            <a:r>
-              <a:t>ENCOURAGING PHRASES:</a:t>
-            </a:r>
-          </a:p>
-          <a:p>
-            <a:r>
-              <a:t>Yum!</a:t>
-            </a:r>
-          </a:p>
-          <a:p/>
-          <a:p>
-            <a:r>
-              <a:t>EASIER OPTION:</a:t>
-            </a:r>
-          </a:p>
-          <a:p>
-            <a:r>
-              <a:t>Two choices.</a:t>
-            </a:r>
-          </a:p>
-          <a:p/>
-          <a:p>
-            <a:r>
-              <a:t>HARDER OPTION:</a:t>
-            </a:r>
-          </a:p>
-          <a:p>
-            <a:r>
-              <a:t>Why pick it?</a:t>
-            </a:r>
-          </a:p>
-          <a:p/>
-          <a:p>
-            <a:r>
-              <a:t>TIMING: 8–9 min</a:t>
-            </a:r>
-          </a:p>
         </p:txBody>
       </p:sp>
       <p:sp>
@@ -4622,88 +2376,7 @@
         <p:txBody>
           <a:bodyPr/>
           <a:lstStyle/>
-          <a:p>
-            <a:r>
-              <a:t>WHAT TO SAY:</a:t>
-            </a:r>
-          </a:p>
-          <a:p>
-            <a:r>
-              <a:t>Pick the story word!</a:t>
-            </a:r>
-          </a:p>
           <a:p/>
-          <a:p>
-            <a:r>
-              <a:t>QUESTION TO ASK:</a:t>
-            </a:r>
-          </a:p>
-          <a:p>
-            <a:r>
-              <a:t>Which one?</a:t>
-            </a:r>
-          </a:p>
-          <a:p/>
-          <a:p>
-            <a:r>
-              <a:t>EXPECTED ANSWER:</a:t>
-            </a:r>
-          </a:p>
-          <a:p>
-            <a:r>
-              <a:t>HOME</a:t>
-            </a:r>
-          </a:p>
-          <a:p/>
-          <a:p>
-            <a:r>
-              <a:t>IF CHILD STRUGGLES:</a:t>
-            </a:r>
-          </a:p>
-          <a:p>
-            <a:r>
-              <a:t>Say each aloud.</a:t>
-            </a:r>
-          </a:p>
-          <a:p/>
-          <a:p>
-            <a:r>
-              <a:t>ENCOURAGING PHRASES:</a:t>
-            </a:r>
-          </a:p>
-          <a:p>
-            <a:r>
-              <a:t>Yum!</a:t>
-            </a:r>
-          </a:p>
-          <a:p/>
-          <a:p>
-            <a:r>
-              <a:t>EASIER OPTION:</a:t>
-            </a:r>
-          </a:p>
-          <a:p>
-            <a:r>
-              <a:t>Two choices.</a:t>
-            </a:r>
-          </a:p>
-          <a:p/>
-          <a:p>
-            <a:r>
-              <a:t>HARDER OPTION:</a:t>
-            </a:r>
-          </a:p>
-          <a:p>
-            <a:r>
-              <a:t>Why pick it?</a:t>
-            </a:r>
-          </a:p>
-          <a:p/>
-          <a:p>
-            <a:r>
-              <a:t>TIMING: 9 min</a:t>
-            </a:r>
-          </a:p>
         </p:txBody>
       </p:sp>
       <p:sp>

</xml_diff>